<commit_message>
Update team leader name to Aniket Kumar across pitch deck and configuration
</commit_message>
<xml_diff>
--- a/public/CampusPulse_TechPulse2026_Submission.pptx
+++ b/public/CampusPulse_TechPulse2026_Submission.pptx
@@ -2556,7 +2556,7 @@
                 <a:ea typeface="Segoe UI" pitchFamily="34" charset="-122"/>
                 <a:cs typeface="Segoe UI" pitchFamily="34" charset="-120"/>
               </a:rPr>
-              <a:t>Team Name: CampusPulse   |   Team Leader: Dharambir   |   Institution: Sri Sairam Engineering College (SSEC), Chennai</a:t>
+              <a:t>Team Name: CampusPulse   |   Team Leader: Aniket Kumar   |   Institution: Sri Sairam Engineering College (SSEC), Chennai</a:t>
             </a:r>
             <a:endParaRPr lang="en-US" sz="1100" dirty="0"/>
           </a:p>
@@ -2855,7 +2855,7 @@
                 <a:ea typeface="Calibri" pitchFamily="34" charset="-122"/>
                 <a:cs typeface="Calibri" pitchFamily="34" charset="-120"/>
               </a:rPr>
-              <a:t>Team CampusPulse | Lead: Dharambir   [ 10 / 12 ]</a:t>
+              <a:t>Team CampusPulse | Lead: Aniket Kumar   [ 10 / 12 ]</a:t>
             </a:r>
             <a:endParaRPr lang="en-US" sz="900" dirty="0"/>
           </a:p>
@@ -4888,7 +4888,7 @@
                 <a:ea typeface="Calibri" pitchFamily="34" charset="-122"/>
                 <a:cs typeface="Calibri" pitchFamily="34" charset="-120"/>
               </a:rPr>
-              <a:t>Team CampusPulse | Lead: Dharambir   [ 11 / 12 ]</a:t>
+              <a:t>Team CampusPulse | Lead: Aniket Kumar   [ 11 / 12 ]</a:t>
             </a:r>
             <a:endParaRPr lang="en-US" sz="900" dirty="0"/>
           </a:p>
@@ -5893,7 +5893,7 @@
                 <a:ea typeface="Calibri" pitchFamily="34" charset="-122"/>
                 <a:cs typeface="Calibri" pitchFamily="34" charset="-120"/>
               </a:rPr>
-              <a:t>Team CampusPulse | Lead: Dharambir   [ 12 / 12 ]</a:t>
+              <a:t>Team CampusPulse | Lead: Aniket Kumar   [ 12 / 12 ]</a:t>
             </a:r>
             <a:endParaRPr lang="en-US" sz="900" dirty="0"/>
           </a:p>
@@ -6752,7 +6752,7 @@
                 <a:ea typeface="Segoe UI" pitchFamily="34" charset="-122"/>
                 <a:cs typeface="Segoe UI" pitchFamily="34" charset="-120"/>
               </a:rPr>
-              <a:t>Team Leader: Dharambir</a:t>
+              <a:t>Team Leader: Aniket Kumar</a:t>
             </a:r>
             <a:endParaRPr lang="en-US" sz="1000" dirty="0"/>
           </a:p>
@@ -7071,7 +7071,7 @@
                 <a:ea typeface="Calibri" pitchFamily="34" charset="-122"/>
                 <a:cs typeface="Calibri" pitchFamily="34" charset="-120"/>
               </a:rPr>
-              <a:t>Team CampusPulse | Lead: Dharambir   [ 2 / 12 ]</a:t>
+              <a:t>Team CampusPulse | Lead: Aniket Kumar   [ 2 / 12 ]</a:t>
             </a:r>
             <a:endParaRPr lang="en-US" sz="900" dirty="0"/>
           </a:p>
@@ -8326,7 +8326,7 @@
                 <a:ea typeface="Calibri" pitchFamily="34" charset="-122"/>
                 <a:cs typeface="Calibri" pitchFamily="34" charset="-120"/>
               </a:rPr>
-              <a:t>Team CampusPulse | Lead: Dharambir   [ 3 / 12 ]</a:t>
+              <a:t>Team CampusPulse | Lead: Aniket Kumar   [ 3 / 12 ]</a:t>
             </a:r>
             <a:endParaRPr lang="en-US" sz="900" dirty="0"/>
           </a:p>
@@ -9353,7 +9353,7 @@
                 <a:ea typeface="Calibri" pitchFamily="34" charset="-122"/>
                 <a:cs typeface="Calibri" pitchFamily="34" charset="-120"/>
               </a:rPr>
-              <a:t>Team CampusPulse | Lead: Dharambir   [ 4 / 12 ]</a:t>
+              <a:t>Team CampusPulse | Lead: Aniket Kumar   [ 4 / 12 ]</a:t>
             </a:r>
             <a:endParaRPr lang="en-US" sz="900" dirty="0"/>
           </a:p>
@@ -10292,7 +10292,7 @@
                 <a:ea typeface="Calibri" pitchFamily="34" charset="-122"/>
                 <a:cs typeface="Calibri" pitchFamily="34" charset="-120"/>
               </a:rPr>
-              <a:t>Team CampusPulse | Lead: Dharambir   [ 5 / 12 ]</a:t>
+              <a:t>Team CampusPulse | Lead: Aniket Kumar   [ 5 / 12 ]</a:t>
             </a:r>
             <a:endParaRPr lang="en-US" sz="900" dirty="0"/>
           </a:p>
@@ -11007,7 +11007,7 @@
                 <a:ea typeface="Calibri" pitchFamily="34" charset="-122"/>
                 <a:cs typeface="Calibri" pitchFamily="34" charset="-120"/>
               </a:rPr>
-              <a:t>Team CampusPulse | Lead: Dharambir   [ 6 / 12 ]</a:t>
+              <a:t>Team CampusPulse | Lead: Aniket Kumar   [ 6 / 12 ]</a:t>
             </a:r>
             <a:endParaRPr lang="en-US" sz="900" dirty="0"/>
           </a:p>
@@ -11936,7 +11936,7 @@
                 <a:ea typeface="Calibri" pitchFamily="34" charset="-122"/>
                 <a:cs typeface="Calibri" pitchFamily="34" charset="-120"/>
               </a:rPr>
-              <a:t>Team CampusPulse | Lead: Dharambir   [ 7 / 12 ]</a:t>
+              <a:t>Team CampusPulse | Lead: Aniket Kumar   [ 7 / 12 ]</a:t>
             </a:r>
             <a:endParaRPr lang="en-US" sz="900" dirty="0"/>
           </a:p>
@@ -12845,7 +12845,7 @@
                 <a:ea typeface="Calibri" pitchFamily="34" charset="-122"/>
                 <a:cs typeface="Calibri" pitchFamily="34" charset="-120"/>
               </a:rPr>
-              <a:t>Team CampusPulse | Lead: Dharambir   [ 8 / 12 ]</a:t>
+              <a:t>Team CampusPulse | Lead: Aniket Kumar   [ 8 / 12 ]</a:t>
             </a:r>
             <a:endParaRPr lang="en-US" sz="900" dirty="0"/>
           </a:p>
@@ -13560,7 +13560,7 @@
                 <a:ea typeface="Calibri" pitchFamily="34" charset="-122"/>
                 <a:cs typeface="Calibri" pitchFamily="34" charset="-120"/>
               </a:rPr>
-              <a:t>Team CampusPulse | Lead: Dharambir   [ 9 / 12 ]</a:t>
+              <a:t>Team CampusPulse | Lead: Aniket Kumar   [ 9 / 12 ]</a:t>
             </a:r>
             <a:endParaRPr lang="en-US" sz="900" dirty="0"/>
           </a:p>

</xml_diff>